<commit_message>
Update projects 01-03: penalty-level P01 sample, accurate P02/P03 wording, en-GB numbers
- 01: every penalty linked to its own taker, fouled player and conceder
  (79 vs 3,456 penalties); difference with Newcombe CI and minimum
  detectable effect; page, methodology, slides and card updated
- 02: method description matches the code (goal value = gap between
  consecutive transitions within a minute bin); brightest cell, Mario Rui
  and own-goal statements reworded; neutral homepage finding
- 03: value-model description matches P02's code; Jackson wording;
  slides.pdf added (the download link was a 404); deck glyph and bar fixes
- methodology.html/.pdf rebuilt with the shared builder for all three
- every number pinned to en-GB; no faux-bold Instrument Serif

Co-Authored-By: Claude Opus 5.5 (1M context) <noreply@anthropic.com>
</commit_message>
<xml_diff>
--- a/projects/01-penalty-analysis/slides.pptx
+++ b/projects/01-penalty-analysis/slides.pptx
@@ -3304,7 +3304,7 @@
                 </a:solidFill>
                 <a:latin typeface="JetBrains Mono"/>
               </a:rPr>
-              <a:t>2026-05</a:t>
+              <a:t>MAY 2026</a:t>
             </a:r>
           </a:p>
         </p:txBody>
@@ -3971,7 +3971,7 @@
                 </a:solidFill>
                 <a:latin typeface="JetBrains Mono"/>
               </a:rPr>
-              <a:t>80.95%</a:t>
+              <a:t>80.00%</a:t>
             </a:r>
           </a:p>
         </p:txBody>
@@ -4006,7 +4006,7 @@
                 </a:solidFill>
                 <a:latin typeface="JetBrains Mono"/>
               </a:rPr>
-              <a:t>21</a:t>
+              <a:t>15</a:t>
             </a:r>
           </a:p>
         </p:txBody>
@@ -4041,7 +4041,7 @@
                 </a:solidFill>
                 <a:latin typeface="JetBrains Mono"/>
               </a:rPr>
-              <a:t>77.70%</a:t>
+              <a:t>78.57%</a:t>
             </a:r>
           </a:p>
         </p:txBody>
@@ -4076,7 +4076,7 @@
                 </a:solidFill>
                 <a:latin typeface="JetBrains Mono"/>
               </a:rPr>
-              <a:t>888</a:t>
+              <a:t>812</a:t>
             </a:r>
           </a:p>
         </p:txBody>
@@ -4111,7 +4111,7 @@
                 </a:solidFill>
                 <a:latin typeface="JetBrains Mono"/>
               </a:rPr>
-              <a:t>+0.354</a:t>
+              <a:t>+0.134</a:t>
             </a:r>
           </a:p>
         </p:txBody>
@@ -4146,7 +4146,7 @@
                 </a:solidFill>
                 <a:latin typeface="JetBrains Mono"/>
               </a:rPr>
-              <a:t>0.6383</a:t>
+              <a:t>0.5532</a:t>
             </a:r>
           </a:p>
         </p:txBody>
@@ -4251,7 +4251,7 @@
                 </a:solidFill>
                 <a:latin typeface="JetBrains Mono"/>
               </a:rPr>
-              <a:t>57.89%</a:t>
+              <a:t>55.56%</a:t>
             </a:r>
           </a:p>
         </p:txBody>
@@ -4286,7 +4286,7 @@
                 </a:solidFill>
                 <a:latin typeface="JetBrains Mono"/>
               </a:rPr>
-              <a:t>19</a:t>
+              <a:t>18</a:t>
             </a:r>
           </a:p>
         </p:txBody>
@@ -4321,7 +4321,7 @@
                 </a:solidFill>
                 <a:latin typeface="JetBrains Mono"/>
               </a:rPr>
-              <a:t>77.46%</a:t>
+              <a:t>77.37%</a:t>
             </a:r>
           </a:p>
         </p:txBody>
@@ -4356,7 +4356,7 @@
                 </a:solidFill>
                 <a:latin typeface="JetBrains Mono"/>
               </a:rPr>
-              <a:t>803</a:t>
+              <a:t>716</a:t>
             </a:r>
           </a:p>
         </p:txBody>
@@ -4391,7 +4391,7 @@
                 </a:solidFill>
                 <a:latin typeface="JetBrains Mono"/>
               </a:rPr>
-              <a:t>-2.003</a:t>
+              <a:t>-2.167</a:t>
             </a:r>
           </a:p>
         </p:txBody>
@@ -4426,7 +4426,7 @@
                 </a:solidFill>
                 <a:latin typeface="JetBrains Mono"/>
               </a:rPr>
-              <a:t>0.0226</a:t>
+              <a:t>0.0151</a:t>
             </a:r>
           </a:p>
         </p:txBody>
@@ -4531,7 +4531,7 @@
                 </a:solidFill>
                 <a:latin typeface="JetBrains Mono"/>
               </a:rPr>
-              <a:t>88.00%</a:t>
+              <a:t>91.30%</a:t>
             </a:r>
           </a:p>
         </p:txBody>
@@ -4566,7 +4566,7 @@
                 </a:solidFill>
                 <a:latin typeface="JetBrains Mono"/>
               </a:rPr>
-              <a:t>25</a:t>
+              <a:t>23</a:t>
             </a:r>
           </a:p>
         </p:txBody>
@@ -4601,7 +4601,7 @@
                 </a:solidFill>
                 <a:latin typeface="JetBrains Mono"/>
               </a:rPr>
-              <a:t>78.59%</a:t>
+              <a:t>79.63%</a:t>
             </a:r>
           </a:p>
         </p:txBody>
@@ -4636,7 +4636,7 @@
                 </a:solidFill>
                 <a:latin typeface="JetBrains Mono"/>
               </a:rPr>
-              <a:t>626</a:t>
+              <a:t>599</a:t>
             </a:r>
           </a:p>
         </p:txBody>
@@ -4671,7 +4671,7 @@
                 </a:solidFill>
                 <a:latin typeface="JetBrains Mono"/>
               </a:rPr>
-              <a:t>+1.131</a:t>
+              <a:t>+1.375</a:t>
             </a:r>
           </a:p>
         </p:txBody>
@@ -4706,7 +4706,7 @@
                 </a:solidFill>
                 <a:latin typeface="JetBrains Mono"/>
               </a:rPr>
-              <a:t>0.8710</a:t>
+              <a:t>0.9154</a:t>
             </a:r>
           </a:p>
         </p:txBody>
@@ -4811,7 +4811,7 @@
                 </a:solidFill>
                 <a:latin typeface="JetBrains Mono"/>
               </a:rPr>
-              <a:t>61.54%</a:t>
+              <a:t>60.00%</a:t>
             </a:r>
           </a:p>
         </p:txBody>
@@ -4846,7 +4846,7 @@
                 </a:solidFill>
                 <a:latin typeface="JetBrains Mono"/>
               </a:rPr>
-              <a:t>13</a:t>
+              <a:t>10</a:t>
             </a:r>
           </a:p>
         </p:txBody>
@@ -4881,7 +4881,7 @@
                 </a:solidFill>
                 <a:latin typeface="JetBrains Mono"/>
               </a:rPr>
-              <a:t>78.18%</a:t>
+              <a:t>79.83%</a:t>
             </a:r>
           </a:p>
         </p:txBody>
@@ -4916,7 +4916,7 @@
                 </a:solidFill>
                 <a:latin typeface="JetBrains Mono"/>
               </a:rPr>
-              <a:t>614</a:t>
+              <a:t>575</a:t>
             </a:r>
           </a:p>
         </p:txBody>
@@ -4951,7 +4951,7 @@
                 </a:solidFill>
                 <a:latin typeface="JetBrains Mono"/>
               </a:rPr>
-              <a:t>-1.429</a:t>
+              <a:t>-1.539</a:t>
             </a:r>
           </a:p>
         </p:txBody>
@@ -4986,7 +4986,7 @@
                 </a:solidFill>
                 <a:latin typeface="JetBrains Mono"/>
               </a:rPr>
-              <a:t>0.0765</a:t>
+              <a:t>0.0619</a:t>
             </a:r>
           </a:p>
         </p:txBody>
@@ -5091,7 +5091,7 @@
                 </a:solidFill>
                 <a:latin typeface="JetBrains Mono"/>
               </a:rPr>
-              <a:t>77.27%</a:t>
+              <a:t>84.62%</a:t>
             </a:r>
           </a:p>
         </p:txBody>
@@ -5126,7 +5126,7 @@
                 </a:solidFill>
                 <a:latin typeface="JetBrains Mono"/>
               </a:rPr>
-              <a:t>22</a:t>
+              <a:t>13</a:t>
             </a:r>
           </a:p>
         </p:txBody>
@@ -5161,7 +5161,7 @@
                 </a:solidFill>
                 <a:latin typeface="JetBrains Mono"/>
               </a:rPr>
-              <a:t>79.42%</a:t>
+              <a:t>79.71%</a:t>
             </a:r>
           </a:p>
         </p:txBody>
@@ -5196,7 +5196,7 @@
                 </a:solidFill>
                 <a:latin typeface="JetBrains Mono"/>
               </a:rPr>
-              <a:t>826</a:t>
+              <a:t>754</a:t>
             </a:r>
           </a:p>
         </p:txBody>
@@ -5231,7 +5231,7 @@
                 </a:solidFill>
                 <a:latin typeface="JetBrains Mono"/>
               </a:rPr>
-              <a:t>-0.245</a:t>
+              <a:t>+0.437</a:t>
             </a:r>
           </a:p>
         </p:txBody>
@@ -5266,7 +5266,7 @@
                 </a:solidFill>
                 <a:latin typeface="JetBrains Mono"/>
               </a:rPr>
-              <a:t>0.4030</a:t>
+              <a:t>0.6689</a:t>
             </a:r>
           </a:p>
         </p:txBody>
@@ -5336,7 +5336,7 @@
                 </a:solidFill>
                 <a:latin typeface="JetBrains Mono"/>
               </a:rPr>
-              <a:t>Per-league treatment cells of 13–25 leave each test severely underpowered — pooled is the only inference to take seriously.</a:t>
+              <a:t>Treatment cells of 10–23 per league: five uncorrected, underpowered tests — the pooled test is the inference.</a:t>
             </a:r>
           </a:p>
         </p:txBody>
@@ -5641,7 +5641,7 @@
                 </a:solidFill>
                 <a:latin typeface="DM Sans"/>
               </a:rPr>
-              <a:t>Conversion is 3.25 pp lower when the fouled player takes the kick himself (75.00% vs 78.25% for everyone else). The point estimate moves in the predicted direction, but the treatment cell is too small to rule chance out (p = 0.218, one-tailed).</a:t>
+              <a:t>Conversion is 3.01 pp lower when the fouled player takes the kick himself (75.95% vs 78.96% for everyone else). The point estimate moves in the predicted direction, but the treatment cell is too small to rule chance out (p = 0.258, one-tailed). With 79 such penalties the design only reliably detects a drop of about 12.6 pp or more.</a:t>
             </a:r>
           </a:p>
         </p:txBody>
@@ -6399,7 +6399,7 @@
                 </a:solidFill>
                 <a:latin typeface="Instrument Serif"/>
               </a:rPr>
-              <a:t>One-tailed two-proportion z-test. Treatment n = 100 (75.0%). Control n = 3,757 (78.25%).</a:t>
+              <a:t>One-tailed two-proportion z-test. Treatment n = 79 (75.95%). Control n = 3,456 (78.96%).</a:t>
             </a:r>
           </a:p>
         </p:txBody>
@@ -6469,7 +6469,7 @@
                 </a:solidFill>
                 <a:latin typeface="Instrument Serif"/>
               </a:rPr>
-              <a:t>Δ = -3.25 pp (predicted direction) but p = 0.218, one-tailed — fail to reject H₀ at the available power.</a:t>
+              <a:t>Δ = -3.01 pp (95% CI -13.6 to +5.2) — predicted direction, but p = 0.258, one-tailed: fail to reject H₀.</a:t>
             </a:r>
           </a:p>
         </p:txBody>
@@ -7254,7 +7254,7 @@
                 </a:solidFill>
                 <a:latin typeface="Instrument Serif"/>
               </a:rPr>
-              <a:t>3,322</a:t>
+              <a:t>3,535</a:t>
             </a:r>
           </a:p>
         </p:txBody>
@@ -7289,7 +7289,7 @@
                 </a:solidFill>
                 <a:latin typeface="JetBrains Mono"/>
               </a:rPr>
-              <a:t>SINGLE-PENALTY MATCHES</a:t>
+              <a:t>LINKED PENALTIES</a:t>
             </a:r>
           </a:p>
         </p:txBody>
@@ -7368,7 +7368,7 @@
                 </a:solidFill>
                 <a:latin typeface="Instrument Serif"/>
               </a:rPr>
-              <a:t>100</a:t>
+              <a:t>79</a:t>
             </a:r>
           </a:p>
         </p:txBody>
@@ -7657,7 +7657,7 @@
                 </a:solidFill>
                 <a:latin typeface="JetBrains Mono"/>
               </a:rPr>
-              <a:t>Strict filter = matches with at most one penalty event (unambiguous GK-caused / taker-was-fouled attribution).</a:t>
+              <a:t>Linked = the team took exactly one penalty in the match, so taker, fouled player and conceder are unambiguous.</a:t>
             </a:r>
           </a:p>
         </p:txBody>
@@ -8023,7 +8023,7 @@
                 </a:solidFill>
                 <a:latin typeface="DM Sans"/>
               </a:rPr>
-              <a:t>Matches where the goalkeeper conceded the foul AND the fouled player is the same player who took the penalty.</a:t>
+              <a:t>Penalties where the goalkeeper conceded the foul AND the fouled player took the penalty himself.</a:t>
             </a:r>
           </a:p>
         </p:txBody>
@@ -8172,7 +8172,7 @@
                 </a:solidFill>
                 <a:latin typeface="DM Sans"/>
               </a:rPr>
-              <a:t>Every other strict-filter match — GK fouled but a different player took, or outfielder caused the foul (any taker).</a:t>
+              <a:t>Every other linked penalty — GK conceded but someone else took it, outfielder conceded (any taker), or no foul recorded (e.g. handball).</a:t>
             </a:r>
           </a:p>
         </p:txBody>
@@ -9123,7 +9123,7 @@
                 </a:solidFill>
                 <a:latin typeface="Instrument Serif"/>
               </a:rPr>
-              <a:t>75.00%</a:t>
+              <a:t>75.95%</a:t>
             </a:r>
           </a:p>
         </p:txBody>
@@ -9158,7 +9158,7 @@
                 </a:solidFill>
                 <a:latin typeface="JetBrains Mono"/>
               </a:rPr>
-              <a:t>n = 100  ·  95% CI [65.70%, 82.45%]</a:t>
+              <a:t>n = 79  ·  95% CI [65.46%, 84.03%]</a:t>
             </a:r>
           </a:p>
         </p:txBody>
@@ -9228,7 +9228,7 @@
                 </a:solidFill>
                 <a:latin typeface="Instrument Serif"/>
               </a:rPr>
-              <a:t>78.25%</a:t>
+              <a:t>78.96%</a:t>
             </a:r>
           </a:p>
         </p:txBody>
@@ -9263,7 +9263,7 @@
                 </a:solidFill>
                 <a:latin typeface="JetBrains Mono"/>
               </a:rPr>
-              <a:t>n = 3,757  ·  95% CI [76.91%, 79.54%]</a:t>
+              <a:t>n = 3,456  ·  95% CI [77.57%, 80.29%]</a:t>
             </a:r>
           </a:p>
         </p:txBody>
@@ -9340,7 +9340,7 @@
                 </a:solidFill>
                 <a:latin typeface="JetBrains Mono"/>
               </a:rPr>
-              <a:t>Δ = -3.25 pp   z = -0.777</a:t>
+              <a:t>Δ = -3.01 pp   z = -0.649</a:t>
             </a:r>
           </a:p>
         </p:txBody>
@@ -9375,7 +9375,7 @@
                 </a:solidFill>
                 <a:latin typeface="JetBrains Mono"/>
               </a:rPr>
-              <a:t>p = 0.2185 (one-tailed)  ·  Fail to reject H₀</a:t>
+              <a:t>p = 0.2581 (one-tailed)  ·  Fail to reject H₀</a:t>
             </a:r>
           </a:p>
         </p:txBody>
@@ -9410,7 +9410,7 @@
                 </a:solidFill>
                 <a:latin typeface="JetBrains Mono"/>
               </a:rPr>
-              <a:t>Whiskers: 95% Wilson confidence intervals. Treatment CI is wide — n is the binding constraint.</a:t>
+              <a:t>Whiskers: 95% Wilson CIs. Difference 95% CI -13.6 to +5.2 pp; smallest detectable drop ≈ 12.6 pp (80% power).</a:t>
             </a:r>
           </a:p>
         </p:txBody>
@@ -10082,7 +10082,7 @@
                 </a:solidFill>
                 <a:latin typeface="Instrument Serif"/>
               </a:rPr>
-              <a:t>75.00%</a:t>
+              <a:t>75.95%</a:t>
             </a:r>
           </a:p>
         </p:txBody>
@@ -10117,7 +10117,7 @@
                 </a:solidFill>
                 <a:latin typeface="JetBrains Mono"/>
               </a:rPr>
-              <a:t>N = 100</a:t>
+              <a:t>N = 79</a:t>
             </a:r>
           </a:p>
         </p:txBody>
@@ -10196,7 +10196,7 @@
                 </a:solidFill>
                 <a:latin typeface="Instrument Serif"/>
               </a:rPr>
-              <a:t>78.87%</a:t>
+              <a:t>79.02%</a:t>
             </a:r>
           </a:p>
         </p:txBody>
@@ -10231,7 +10231,7 @@
                 </a:solidFill>
                 <a:latin typeface="JetBrains Mono"/>
               </a:rPr>
-              <a:t>N = 549</a:t>
+              <a:t>N = 491</a:t>
             </a:r>
           </a:p>
         </p:txBody>
@@ -10310,7 +10310,7 @@
                 </a:solidFill>
                 <a:latin typeface="JetBrains Mono"/>
               </a:rPr>
-              <a:t>TAKER = A DIFFERENT PLAYER</a:t>
+              <a:t>TAKER = NOT THE FOULED PLAYER (INCL. HANDBALLS)</a:t>
             </a:r>
           </a:p>
         </p:txBody>
@@ -10389,7 +10389,7 @@
                 </a:solidFill>
                 <a:latin typeface="Instrument Serif"/>
               </a:rPr>
-              <a:t>78.11%</a:t>
+              <a:t>78.33%</a:t>
             </a:r>
           </a:p>
         </p:txBody>
@@ -10424,7 +10424,7 @@
                 </a:solidFill>
                 <a:latin typeface="JetBrains Mono"/>
               </a:rPr>
-              <a:t>N = 265</a:t>
+              <a:t>N = 203</a:t>
             </a:r>
           </a:p>
         </p:txBody>
@@ -10503,7 +10503,7 @@
                 </a:solidFill>
                 <a:latin typeface="Instrument Serif"/>
               </a:rPr>
-              <a:t>78.15%</a:t>
+              <a:t>79.00%</a:t>
             </a:r>
           </a:p>
         </p:txBody>
@@ -10538,7 +10538,7 @@
                 </a:solidFill>
                 <a:latin typeface="JetBrains Mono"/>
               </a:rPr>
-              <a:t>N = 2,943</a:t>
+              <a:t>N = 2,762</a:t>
             </a:r>
           </a:p>
         </p:txBody>

</xml_diff>

<commit_message>
Project 01: dot-and-interval charts, house style, bootstrap cache
- League, season and treatment-vs-control charts on the page and in the deck
  are dots with 95% Wilson intervals instead of bars on a truncated axis;
  Wilson intervals for league and season rates added to data.json
- Bootstrap results cached by a hash of their inputs (rebuild ~2 min, was ~14)
- Copy without em dashes; clubs takeaway in plain words
- X package rewritten to the house style (kept local)

Co-Authored-By: Claude Opus 5.5 (1M context) <noreply@anthropic.com>
</commit_message>
<xml_diff>
--- a/projects/01-penalty-analysis/slides.pptx
+++ b/projects/01-penalty-analysis/slides.pptx
@@ -4557,7 +4557,7 @@
                 </a:solidFill>
                 <a:latin typeface="DM Sans"/>
               </a:rPr>
-              <a:t>Split-half, 126 takers with 10+ kicks (95% CI −0.47 to 0.18). A taker's hit rate on alternate kicks says nothing useful about the rest — penalty records behave like noise at these sample sizes.</a:t>
+              <a:t>Split-half, 126 takers with 10+ kicks (95% CI −0.47 to 0.18). A taker's hit rate on alternate kicks says nothing useful about the rest: penalty records behave like noise at these sample sizes.</a:t>
             </a:r>
           </a:p>
         </p:txBody>
@@ -4592,7 +4592,7 @@
                 </a:solidFill>
                 <a:latin typeface="JetBrains Mono"/>
               </a:rPr>
-              <a:t>Define the taker from the whole season instead and the edge jumps to +11.37 pp — largely the outcome leaking in: takers who miss lose the job.</a:t>
+              <a:t>Define the taker from the whole season instead and the edge jumps to +11.37 pp, largely the outcome leaking in: takers who miss lose the job.</a:t>
             </a:r>
           </a:p>
         </p:txBody>
@@ -9476,7 +9476,7 @@
                 </a:solidFill>
                 <a:latin typeface="DM Sans"/>
               </a:rPr>
-              <a:t>Don't pay for a penalty record: a taker's hit rate on alternate kicks didn't predict the rest (reliability −0.08).</a:t>
+              <a:t>Don't pay for a penalty record: how a taker did on half his kicks didn't predict the other half.</a:t>
             </a:r>
           </a:p>
         </p:txBody>
@@ -9511,7 +9511,7 @@
                 </a:solidFill>
                 <a:latin typeface="JetBrains Mono"/>
               </a:rPr>
-              <a:t>126 takers with 10+ kicks · split-half · 95% CI −0.47 to 0.18</a:t>
+              <a:t>126 takers with 10+ kicks · split-half reliability −0.08 · 95% CI −0.47 to 0.18</a:t>
             </a:r>
           </a:p>
         </p:txBody>
@@ -10630,37 +10630,44 @@
       </p:sp>
       <p:sp>
         <p:nvSpPr>
-          <p:cNvPr id="6" name="TextBox 5"/>
-          <p:cNvSpPr txBox="1"/>
-          <p:nvPr/>
-        </p:nvSpPr>
-        <p:spPr>
-          <a:xfrm>
-            <a:off x="640080" y="1463040"/>
-            <a:ext cx="365760" cy="777240"/>
-          </a:xfrm>
-          <a:prstGeom prst="rect">
-            <a:avLst/>
-          </a:prstGeom>
-          <a:noFill/>
-        </p:spPr>
-        <p:txBody>
-          <a:bodyPr wrap="square" lIns="0" rIns="0" tIns="0" bIns="0" anchor="t">
-            <a:spAutoFit/>
-          </a:bodyPr>
-          <a:lstStyle/>
-          <a:p>
-            <a:pPr algn="l"/>
-            <a:r>
-              <a:rPr sz="2200" b="0" i="0">
-                <a:solidFill>
-                  <a:srgbClr val="C1FF72"/>
-                </a:solidFill>
-                <a:latin typeface="Instrument Serif"/>
-              </a:rPr>
-              <a:t>—</a:t>
-            </a:r>
-          </a:p>
+          <p:cNvPr id="6" name="Rectangle 5"/>
+          <p:cNvSpPr/>
+          <p:nvPr/>
+        </p:nvSpPr>
+        <p:spPr>
+          <a:xfrm>
+            <a:off x="685800" y="1618488"/>
+            <a:ext cx="82296" cy="82296"/>
+          </a:xfrm>
+          <a:prstGeom prst="rect">
+            <a:avLst/>
+          </a:prstGeom>
+          <a:solidFill>
+            <a:srgbClr val="C1FF72"/>
+          </a:solidFill>
+          <a:ln>
+            <a:noFill/>
+          </a:ln>
+          <a:effectLst/>
+        </p:spPr>
+        <p:style>
+          <a:lnRef idx="1">
+            <a:schemeClr val="accent1"/>
+          </a:lnRef>
+          <a:fillRef idx="3">
+            <a:schemeClr val="accent1"/>
+          </a:fillRef>
+          <a:effectRef idx="2">
+            <a:schemeClr val="accent1"/>
+          </a:effectRef>
+          <a:fontRef idx="minor">
+            <a:schemeClr val="lt1"/>
+          </a:fontRef>
+        </p:style>
+        <p:txBody>
+          <a:bodyPr rtlCol="0" anchor="ctr" lIns="0" rIns="0" tIns="0" bIns="0"/>
+          <a:lstStyle/>
+          <a:p/>
         </p:txBody>
       </p:sp>
       <p:sp>
@@ -10693,44 +10700,51 @@
                 </a:solidFill>
                 <a:latin typeface="DM Sans"/>
               </a:rPr>
-              <a:t>Small treatment group: 79 penalties — a real drop below ~12.6 pp would usually go unseen.</a:t>
-            </a:r>
-          </a:p>
-        </p:txBody>
-      </p:sp>
-      <p:sp>
-        <p:nvSpPr>
-          <p:cNvPr id="8" name="TextBox 7"/>
-          <p:cNvSpPr txBox="1"/>
-          <p:nvPr/>
-        </p:nvSpPr>
-        <p:spPr>
-          <a:xfrm>
-            <a:off x="640080" y="2377440"/>
-            <a:ext cx="365760" cy="777240"/>
-          </a:xfrm>
-          <a:prstGeom prst="rect">
-            <a:avLst/>
-          </a:prstGeom>
-          <a:noFill/>
-        </p:spPr>
-        <p:txBody>
-          <a:bodyPr wrap="square" lIns="0" rIns="0" tIns="0" bIns="0" anchor="t">
-            <a:spAutoFit/>
-          </a:bodyPr>
-          <a:lstStyle/>
-          <a:p>
-            <a:pPr algn="l"/>
-            <a:r>
-              <a:rPr sz="2200" b="0" i="0">
-                <a:solidFill>
-                  <a:srgbClr val="C1FF72"/>
-                </a:solidFill>
-                <a:latin typeface="Instrument Serif"/>
-              </a:rPr>
-              <a:t>—</a:t>
-            </a:r>
-          </a:p>
+              <a:t>Small treatment group: 79 penalties: a real drop below ~12.6 pp would usually go unseen.</a:t>
+            </a:r>
+          </a:p>
+        </p:txBody>
+      </p:sp>
+      <p:sp>
+        <p:nvSpPr>
+          <p:cNvPr id="8" name="Rectangle 7"/>
+          <p:cNvSpPr/>
+          <p:nvPr/>
+        </p:nvSpPr>
+        <p:spPr>
+          <a:xfrm>
+            <a:off x="685800" y="2532888"/>
+            <a:ext cx="82296" cy="82296"/>
+          </a:xfrm>
+          <a:prstGeom prst="rect">
+            <a:avLst/>
+          </a:prstGeom>
+          <a:solidFill>
+            <a:srgbClr val="C1FF72"/>
+          </a:solidFill>
+          <a:ln>
+            <a:noFill/>
+          </a:ln>
+          <a:effectLst/>
+        </p:spPr>
+        <p:style>
+          <a:lnRef idx="1">
+            <a:schemeClr val="accent1"/>
+          </a:lnRef>
+          <a:fillRef idx="3">
+            <a:schemeClr val="accent1"/>
+          </a:fillRef>
+          <a:effectRef idx="2">
+            <a:schemeClr val="accent1"/>
+          </a:effectRef>
+          <a:fontRef idx="minor">
+            <a:schemeClr val="lt1"/>
+          </a:fontRef>
+        </p:style>
+        <p:txBody>
+          <a:bodyPr rtlCol="0" anchor="ctr" lIns="0" rIns="0" tIns="0" bIns="0"/>
+          <a:lstStyle/>
+          <a:p/>
         </p:txBody>
       </p:sp>
       <p:sp>
@@ -10770,37 +10784,44 @@
       </p:sp>
       <p:sp>
         <p:nvSpPr>
-          <p:cNvPr id="10" name="TextBox 9"/>
-          <p:cNvSpPr txBox="1"/>
-          <p:nvPr/>
-        </p:nvSpPr>
-        <p:spPr>
-          <a:xfrm>
-            <a:off x="640080" y="3291840"/>
-            <a:ext cx="365760" cy="777240"/>
-          </a:xfrm>
-          <a:prstGeom prst="rect">
-            <a:avLst/>
-          </a:prstGeom>
-          <a:noFill/>
-        </p:spPr>
-        <p:txBody>
-          <a:bodyPr wrap="square" lIns="0" rIns="0" tIns="0" bIns="0" anchor="t">
-            <a:spAutoFit/>
-          </a:bodyPr>
-          <a:lstStyle/>
-          <a:p>
-            <a:pPr algn="l"/>
-            <a:r>
-              <a:rPr sz="2200" b="0" i="0">
-                <a:solidFill>
-                  <a:srgbClr val="C1FF72"/>
-                </a:solidFill>
-                <a:latin typeface="Instrument Serif"/>
-              </a:rPr>
-              <a:t>—</a:t>
-            </a:r>
-          </a:p>
+          <p:cNvPr id="10" name="Rectangle 9"/>
+          <p:cNvSpPr/>
+          <p:nvPr/>
+        </p:nvSpPr>
+        <p:spPr>
+          <a:xfrm>
+            <a:off x="685800" y="3447288"/>
+            <a:ext cx="82296" cy="82296"/>
+          </a:xfrm>
+          <a:prstGeom prst="rect">
+            <a:avLst/>
+          </a:prstGeom>
+          <a:solidFill>
+            <a:srgbClr val="C1FF72"/>
+          </a:solidFill>
+          <a:ln>
+            <a:noFill/>
+          </a:ln>
+          <a:effectLst/>
+        </p:spPr>
+        <p:style>
+          <a:lnRef idx="1">
+            <a:schemeClr val="accent1"/>
+          </a:lnRef>
+          <a:fillRef idx="3">
+            <a:schemeClr val="accent1"/>
+          </a:fillRef>
+          <a:effectRef idx="2">
+            <a:schemeClr val="accent1"/>
+          </a:effectRef>
+          <a:fontRef idx="minor">
+            <a:schemeClr val="lt1"/>
+          </a:fontRef>
+        </p:style>
+        <p:txBody>
+          <a:bodyPr rtlCol="0" anchor="ctr" lIns="0" rIns="0" tIns="0" bIns="0"/>
+          <a:lstStyle/>
+          <a:p/>
         </p:txBody>
       </p:sp>
       <p:sp>
@@ -10840,37 +10861,44 @@
       </p:sp>
       <p:sp>
         <p:nvSpPr>
-          <p:cNvPr id="12" name="TextBox 11"/>
-          <p:cNvSpPr txBox="1"/>
-          <p:nvPr/>
-        </p:nvSpPr>
-        <p:spPr>
-          <a:xfrm>
-            <a:off x="640080" y="4206240"/>
-            <a:ext cx="365760" cy="777240"/>
-          </a:xfrm>
-          <a:prstGeom prst="rect">
-            <a:avLst/>
-          </a:prstGeom>
-          <a:noFill/>
-        </p:spPr>
-        <p:txBody>
-          <a:bodyPr wrap="square" lIns="0" rIns="0" tIns="0" bIns="0" anchor="t">
-            <a:spAutoFit/>
-          </a:bodyPr>
-          <a:lstStyle/>
-          <a:p>
-            <a:pPr algn="l"/>
-            <a:r>
-              <a:rPr sz="2200" b="0" i="0">
-                <a:solidFill>
-                  <a:srgbClr val="C1FF72"/>
-                </a:solidFill>
-                <a:latin typeface="Instrument Serif"/>
-              </a:rPr>
-              <a:t>—</a:t>
-            </a:r>
-          </a:p>
+          <p:cNvPr id="12" name="Rectangle 11"/>
+          <p:cNvSpPr/>
+          <p:nvPr/>
+        </p:nvSpPr>
+        <p:spPr>
+          <a:xfrm>
+            <a:off x="685800" y="4361688"/>
+            <a:ext cx="82296" cy="82296"/>
+          </a:xfrm>
+          <a:prstGeom prst="rect">
+            <a:avLst/>
+          </a:prstGeom>
+          <a:solidFill>
+            <a:srgbClr val="C1FF72"/>
+          </a:solidFill>
+          <a:ln>
+            <a:noFill/>
+          </a:ln>
+          <a:effectLst/>
+        </p:spPr>
+        <p:style>
+          <a:lnRef idx="1">
+            <a:schemeClr val="accent1"/>
+          </a:lnRef>
+          <a:fillRef idx="3">
+            <a:schemeClr val="accent1"/>
+          </a:fillRef>
+          <a:effectRef idx="2">
+            <a:schemeClr val="accent1"/>
+          </a:effectRef>
+          <a:fontRef idx="minor">
+            <a:schemeClr val="lt1"/>
+          </a:fontRef>
+        </p:style>
+        <p:txBody>
+          <a:bodyPr rtlCol="0" anchor="ctr" lIns="0" rIns="0" tIns="0" bIns="0"/>
+          <a:lstStyle/>
+          <a:p/>
         </p:txBody>
       </p:sp>
       <p:sp>
@@ -10903,44 +10931,51 @@
                 </a:solidFill>
                 <a:latin typeface="DM Sans"/>
               </a:rPr>
-              <a:t>No minute, scoreline or goalkeeper in the model — the player-match table has neither.</a:t>
-            </a:r>
-          </a:p>
-        </p:txBody>
-      </p:sp>
-      <p:sp>
-        <p:nvSpPr>
-          <p:cNvPr id="14" name="TextBox 13"/>
-          <p:cNvSpPr txBox="1"/>
-          <p:nvPr/>
-        </p:nvSpPr>
-        <p:spPr>
-          <a:xfrm>
-            <a:off x="640080" y="5120640"/>
-            <a:ext cx="365760" cy="777240"/>
-          </a:xfrm>
-          <a:prstGeom prst="rect">
-            <a:avLst/>
-          </a:prstGeom>
-          <a:noFill/>
-        </p:spPr>
-        <p:txBody>
-          <a:bodyPr wrap="square" lIns="0" rIns="0" tIns="0" bIns="0" anchor="t">
-            <a:spAutoFit/>
-          </a:bodyPr>
-          <a:lstStyle/>
-          <a:p>
-            <a:pPr algn="l"/>
-            <a:r>
-              <a:rPr sz="2200" b="0" i="0">
-                <a:solidFill>
-                  <a:srgbClr val="C1FF72"/>
-                </a:solidFill>
-                <a:latin typeface="Instrument Serif"/>
-              </a:rPr>
-              <a:t>—</a:t>
-            </a:r>
-          </a:p>
+              <a:t>No minute, scoreline or goalkeeper in the model: the player-match table has neither.</a:t>
+            </a:r>
+          </a:p>
+        </p:txBody>
+      </p:sp>
+      <p:sp>
+        <p:nvSpPr>
+          <p:cNvPr id="14" name="Rectangle 13"/>
+          <p:cNvSpPr/>
+          <p:nvPr/>
+        </p:nvSpPr>
+        <p:spPr>
+          <a:xfrm>
+            <a:off x="685800" y="5276088"/>
+            <a:ext cx="82296" cy="82296"/>
+          </a:xfrm>
+          <a:prstGeom prst="rect">
+            <a:avLst/>
+          </a:prstGeom>
+          <a:solidFill>
+            <a:srgbClr val="C1FF72"/>
+          </a:solidFill>
+          <a:ln>
+            <a:noFill/>
+          </a:ln>
+          <a:effectLst/>
+        </p:spPr>
+        <p:style>
+          <a:lnRef idx="1">
+            <a:schemeClr val="accent1"/>
+          </a:lnRef>
+          <a:fillRef idx="3">
+            <a:schemeClr val="accent1"/>
+          </a:fillRef>
+          <a:effectRef idx="2">
+            <a:schemeClr val="accent1"/>
+          </a:effectRef>
+          <a:fontRef idx="minor">
+            <a:schemeClr val="lt1"/>
+          </a:fontRef>
+        </p:style>
+        <p:txBody>
+          <a:bodyPr rtlCol="0" anchor="ctr" lIns="0" rIns="0" tIns="0" bIns="0"/>
+          <a:lstStyle/>
+          <a:p/>
         </p:txBody>
       </p:sp>
       <p:sp>
@@ -11705,7 +11740,7 @@
                 </a:solidFill>
                 <a:latin typeface="JetBrains Mono"/>
               </a:rPr>
-              <a:t>→ code/build.py    Python pipeline — raw pickles → aggregated JSON</a:t>
+              <a:t>→ code/build.py    Python pipeline: raw pickles → aggregated JSON</a:t>
             </a:r>
           </a:p>
         </p:txBody>
@@ -12106,7 +12141,7 @@
                 </a:solidFill>
                 <a:latin typeface="Instrument Serif"/>
               </a:rPr>
-              <a:t>Δ = −3.01 pp (95% CI −13.6 to +5.2) — predicted direction, but p = 0.258: not detectable. Every check agrees (−3.25 pp after controls).</a:t>
+              <a:t>Δ = −3.01 pp (95% CI −13.6 to +5.2): the predicted direction, but p = 0.258: not detectable. Every check agrees (−3.25 pp after controls).</a:t>
             </a:r>
           </a:p>
         </p:txBody>
@@ -12411,7 +12446,7 @@
                 </a:solidFill>
                 <a:latin typeface="DM Sans"/>
               </a:rPr>
-              <a:t>Theory of the taker: physically jarred — body contact, hit the ground, adrenaline. Emotionally agitated, narrowed focus.</a:t>
+              <a:t>Theory of the taker: physically jarred (body contact, hit the ground, adrenaline). Emotionally agitated, narrowed focus.</a:t>
             </a:r>
           </a:p>
         </p:txBody>
@@ -13809,7 +13844,7 @@
                 </a:solidFill>
                 <a:latin typeface="DM Sans"/>
               </a:rPr>
-              <a:t>Every other linked penalty — GK conceded but someone else took it, outfielder conceded (any taker), or no foul recorded (e.g. handball).</a:t>
+              <a:t>Every other linked penalty: GK conceded but someone else took it, outfielder conceded (any taker), or no foul recorded (e.g. handball).</a:t>
             </a:r>
           </a:p>
         </p:txBody>
@@ -14120,7 +14155,7 @@
                 </a:solidFill>
                 <a:latin typeface="JetBrains Mono"/>
               </a:rPr>
-              <a:t>Across the top 5 leagues conversion clusters tightly in the high 70s — league of origin is not a major source of variation.</a:t>
+              <a:t>Across the top 5 leagues conversion clusters tightly in the high 70s: league of origin is not a major source of variation. Dots: rate; lines: 95% Wilson intervals.</a:t>
             </a:r>
           </a:p>
         </p:txBody>
@@ -15047,7 +15082,7 @@
                 </a:solidFill>
                 <a:latin typeface="JetBrains Mono"/>
               </a:rPr>
-              <a:t>Whiskers: 95% Wilson CIs. Difference 95% CI -13.6 to +5.2 pp; smallest detectable drop ≈ 12.6 pp (80% power).</a:t>
+              <a:t>Lines: 95% Wilson intervals. Difference 95% CI -13.6 to +5.2 pp; smallest detectable drop ≈ 12.6 pp (80% power).</a:t>
             </a:r>
           </a:p>
         </p:txBody>

</xml_diff>